<commit_message>
Rename product Sightline → Dhristi
User-facing strings, package/extension IDs, protocol schemes, docs,
decks, and regenerated extension zips now use Dhristi (user spelling).
Repo slug and GitHub Pages path sih-2026 unchanged. CONTEXT notes the
2026-09-14 rename and Devpost SightLine name collision.
</commit_message>
<xml_diff>
--- a/Docs/pitch-deck.pptx
+++ b/Docs/pitch-deck.pptx
@@ -516,7 +516,7 @@
           <a:lstStyle/>
           <a:p>
             <a:r>
-              <a:t>1 · Sightline</a:t>
+              <a:t>1 · Dhristi</a:t>
             </a:r>
           </a:p>
           <a:p>
@@ -527,7 +527,7 @@
           <a:p/>
           <a:p>
             <a:r>
-              <a:t>Sightline is our working response to SIH26171: on-device visual perception for lightweight browser agents. The central idea is simple: the browser retains the original screen, constructs a protected description and sends only that description to a reasoning server. The user then reviews a bounded action before it executes. This is an implemented engineering candidate, with its limits visible.</a:t>
+              <a:t>Dhristi is our working response to SIH26171: on-device visual perception for lightweight browser agents. The central idea is simple: the browser retains the original screen, constructs a protected description and sends only that description to a reasoning server. The user then reviews a bounded action before it executes. This is an implemented engineering candidate, with its limits visible.</a:t>
             </a:r>
           </a:p>
           <a:p/>
@@ -1079,7 +1079,7 @@
           <a:p/>
           <a:p>
             <a:r>
-              <a:t>Sightline already connects real browser-local inference, a protected scene, a real reasoning model and a reviewed action on a synthetic task. Its current result is an inspectable engineering boundary, not a promise of zero leakage or universal automation. The next decision is to evaluate that boundary on held-out tasks and measure what is protected, what remains useful and what it costs. We invite evaluation of the demonstrated mechanism and its explicit limits. The complete source and evidence registers travel with the build.</a:t>
+              <a:t>Dhristi already connects real browser-local inference, a protected scene, a real reasoning model and a reviewed action on a synthetic task. Its current result is an inspectable engineering boundary, not a promise of zero leakage or universal automation. The next decision is to evaluate that boundary on held-out tasks and measure what is protected, what remains useful and what it costs. We invite evaluation of the demonstrated mechanism and its explicit limits. The complete source and evidence registers travel with the build.</a:t>
             </a:r>
           </a:p>
           <a:p/>
@@ -1263,7 +1263,7 @@
           <a:p/>
           <a:p>
             <a:r>
-              <a:t>The official statement allocates twenty-five percent to visual-context accuracy; twenty percent each to PII detection, redaction precision and client resource use; and fifteen percent to overall task latency. These are organizer weights, not measured scores for Sightline. They make the trade-off explicit: removing everything may control exposure while failing utility. We therefore need separate detection, redaction and task-success measurements. The organizer has not published complete normalization formulas, so we will not invent a weighted total. Current integration observations are useful for debugging, but they cannot stand in for dataset accuracy or a predicted jury outcome.</a:t>
+              <a:t>The official statement allocates twenty-five percent to visual-context accuracy; twenty percent each to PII detection, redaction precision and client resource use; and fifteen percent to overall task latency. These are organizer weights, not measured scores for Dhristi. They make the trade-off explicit: removing everything may control exposure while failing utility. We therefore need separate detection, redaction and task-success measurements. The organizer has not published complete normalization formulas, so we will not invent a weighted total. Current integration observations are useful for debugging, but they cannot stand in for dataset accuracy or a predicted jury outcome.</a:t>
             </a:r>
           </a:p>
           <a:p/>
@@ -4913,7 +4913,7 @@
               </a:defRPr>
             </a:pPr>
             <a:r>
-              <a:t>SIGHTLINE / SIH26171</a:t>
+              <a:t>DHRISTI / SIH26171</a:t>
             </a:r>
           </a:p>
         </p:txBody>
@@ -5007,7 +5007,7 @@
               </a:defRPr>
             </a:pPr>
             <a:r>
-              <a:t>Sightline · On-device Visual Perception for Light-weight Browser Agents</a:t>
+              <a:t>Dhristi · On-device Visual Perception for Light-weight Browser Agents</a:t>
             </a:r>
           </a:p>
         </p:txBody>
@@ -5432,7 +5432,7 @@
               </a:defRPr>
             </a:pPr>
             <a:r>
-              <a:t>SIGHTLINE / SIH26171</a:t>
+              <a:t>DHRISTI / SIH26171</a:t>
             </a:r>
           </a:p>
         </p:txBody>
@@ -6144,7 +6144,7 @@
               </a:defRPr>
             </a:pPr>
             <a:r>
-              <a:t>SIGHTLINE / SIH26171</a:t>
+              <a:t>DHRISTI / SIH26171</a:t>
             </a:r>
           </a:p>
         </p:txBody>
@@ -6937,7 +6937,7 @@
               </a:defRPr>
             </a:pPr>
             <a:r>
-              <a:t>SIGHTLINE / SIH26171</a:t>
+              <a:t>DHRISTI / SIH26171</a:t>
             </a:r>
           </a:p>
         </p:txBody>
@@ -7847,7 +7847,7 @@
               </a:defRPr>
             </a:pPr>
             <a:r>
-              <a:t>SIGHTLINE / SIH26171</a:t>
+              <a:t>DHRISTI / SIH26171</a:t>
             </a:r>
           </a:p>
         </p:txBody>
@@ -8616,7 +8616,7 @@
               </a:defRPr>
             </a:pPr>
             <a:r>
-              <a:t>SIGHTLINE / SIH26171</a:t>
+              <a:t>DHRISTI / SIH26171</a:t>
             </a:r>
           </a:p>
         </p:txBody>
@@ -9710,7 +9710,7 @@
               </a:defRPr>
             </a:pPr>
             <a:r>
-              <a:t>SIGHTLINE / SIH26171</a:t>
+              <a:t>DHRISTI / SIH26171</a:t>
             </a:r>
           </a:p>
         </p:txBody>
@@ -9804,7 +9804,7 @@
               </a:defRPr>
             </a:pPr>
             <a:r>
-              <a:t>Sightline demonstrates a reviewed browser-agent loop; evaluation determines how far it can go.</a:t>
+              <a:t>Dhristi demonstrates a reviewed browser-agent loop; evaluation determines how far it can go.</a:t>
             </a:r>
           </a:p>
         </p:txBody>
@@ -10181,7 +10181,7 @@
               </a:defRPr>
             </a:pPr>
             <a:r>
-              <a:t>SIGHTLINE / SIH26171</a:t>
+              <a:t>DHRISTI / SIH26171</a:t>
             </a:r>
           </a:p>
         </p:txBody>
@@ -10881,7 +10881,7 @@
               </a:defRPr>
             </a:pPr>
             <a:r>
-              <a:t>SIGHTLINE / SIH26171</a:t>
+              <a:t>DHRISTI / SIH26171</a:t>
             </a:r>
           </a:p>
         </p:txBody>
@@ -11823,7 +11823,7 @@
               </a:defRPr>
             </a:pPr>
             <a:r>
-              <a:t>SIGHTLINE / SIH26171</a:t>
+              <a:t>DHRISTI / SIH26171</a:t>
             </a:r>
           </a:p>
         </p:txBody>
@@ -12891,7 +12891,7 @@
               </a:defRPr>
             </a:pPr>
             <a:r>
-              <a:t>SIGHTLINE / SIH26171</a:t>
+              <a:t>DHRISTI / SIH26171</a:t>
             </a:r>
           </a:p>
         </p:txBody>
@@ -13376,7 +13376,7 @@
               </a:defRPr>
             </a:pPr>
             <a:r>
-              <a:t>SIGHTLINE / SIH26171</a:t>
+              <a:t>DHRISTI / SIH26171</a:t>
             </a:r>
           </a:p>
         </p:txBody>
@@ -14241,7 +14241,7 @@
               </a:defRPr>
             </a:pPr>
             <a:r>
-              <a:t>SIGHTLINE / SIH26171</a:t>
+              <a:t>DHRISTI / SIH26171</a:t>
             </a:r>
           </a:p>
         </p:txBody>
@@ -14870,7 +14870,7 @@
               </a:defRPr>
             </a:pPr>
             <a:r>
-              <a:t>SIGHTLINE / SIH26171</a:t>
+              <a:t>DHRISTI / SIH26171</a:t>
             </a:r>
           </a:p>
         </p:txBody>
@@ -15856,7 +15856,7 @@
               </a:defRPr>
             </a:pPr>
             <a:r>
-              <a:t>SIGHTLINE / SIH26171</a:t>
+              <a:t>DHRISTI / SIH26171</a:t>
             </a:r>
           </a:p>
         </p:txBody>

</xml_diff>

<commit_message>
blind(cycle-02): runnable Score risk path + Ollama-free Fast judge
Wire a local heuristic Score path after Fast protect (officialScore null,
≈65% organizer weights cited as evaluation-only). Add one-command
judge-fast-path without Ollama. Align pitch/submission decks and notes
to the measured 119-test count; rebuild extension packages.
</commit_message>
<xml_diff>
--- a/Docs/pitch-deck.pptx
+++ b/Docs/pitch-deck.pptx
@@ -619,7 +619,7 @@
           <a:p/>
           <a:p>
             <a:r>
-              <a:t>The measurement story needs precision. A scale matrix ran the packaged face model over one synthetic image at fourteen sizes from forty-eight to three hundred and twenty pixels: every size returned one detection, between nine and twenty milliseconds. Capture and protection measured ninety-two to one hundred and eight milliseconds across the recorded desktop, initial and narrow-viewport captures. An integrated synthetic observation desk completed a local draft in thirty point five seconds including the human confirmation step, and two further runs stopped correctly on expiry and on user request. A separate first live model step displayed three thousand and twenty-nine milliseconds. One result went against us and it is on the slide: on one hundred frozen synthetic screens, local OCR and the PII model retained exact annotated personal data on fifty-eight of them. That is why text export stays disabled and the outbound schema stays structural. These are local observations on an Apple M1 Pro with sixteen gigabytes of system memory, not distributions or a mobile benchmark. Seventy-five recorded Node tests pass. The original two-hundred-millisecond full-flow target is failed, and we are not rebranding the fastest component as the whole pipeline.</a:t>
+              <a:t>The measurement story needs precision. A scale matrix ran the packaged face model over one synthetic image at fourteen sizes from forty-eight to three hundred and twenty pixels: every size returned one detection, between nine and twenty milliseconds. Capture and protection measured ninety-two to one hundred and eight milliseconds across the recorded desktop, initial and narrow-viewport captures. An integrated synthetic observation desk completed a local draft in thirty point five seconds including the human confirmation step, and two further runs stopped correctly on expiry and on user request. A separate first live model step displayed three thousand and twenty-nine milliseconds. One result went against us and it is on the slide: on one hundred frozen synthetic screens, local OCR and the PII model retained exact annotated personal data on fifty-eight of them. That is why text export stays disabled and the outbound schema stays structural. These are local observations on an Apple M1 Pro with sixteen gigabytes of system memory, not distributions or a mobile benchmark. One hundred nineteen recorded Node tests pass (2026-09-15). The original two-hundred-millisecond full-flow target is failed, and we are not rebranding the fastest component as the whole pipeline.</a:t>
             </a:r>
           </a:p>
           <a:p/>
@@ -6001,7 +6001,7 @@
               </a:defRPr>
             </a:pPr>
             <a:r>
-              <a:t>75 recorded Node tests pass. The &lt;200 ms full-flow target does not pass.</a:t>
+              <a:t>119 recorded Node tests pass (2026-09-15). The &lt;200 ms full-flow target does not pass.</a:t>
             </a:r>
           </a:p>
         </p:txBody>

</xml_diff>